<commit_message>
CIPD deck: David's edits - co-branded not white-label, no cohorts, 'Possible next steps' with Step labels
Co-Authored-By: Claude Fable 5 <noreply@anthropic.com>
</commit_message>
<xml_diff>
--- a/CIPD/deck/GWTH-CIPD-2026-08-20.pptx
+++ b/CIPD/deck/GWTH-CIPD-2026-08-20.pptx
@@ -1127,7 +1127,7 @@
           <a:p>
             <a:r>
               <a:rPr lang="en-US" dirty="0"/>
-              <a:t>This is the 'different wrapper' Ben suggested on 12 August. Be clear what exists: the Teams page promises a dashboard, per-role optional lessons and bespoke lessons for 100+ seats; the curated-edition layer on top (branding, paths, cohort reports, hand-offs) is what I will build and show the week after this call. The whole point is that CIPD does not write or maintain the lessons: one core, updated monthly, many wrappers.</a:t>
+              <a:t>This is the 'different wrapper' Ben suggested on 12 August. Be clear what exists: the Teams page promises a dashboard, per-role optional lessons and bespoke lessons for 100+ seats; the curated-edition layer on top (co-branding, paths, the CIPD pathway on the certificate, hand-offs) is what I will build and show the week after this call. Not white-labelled: it stays visibly GWTH, co-branded with CIPD. No cohorts in the first version (too much to manage); the tooling for employer cohorts with a dashboard could be built later if CIPD wants it. The whole point is that CIPD does not write or maintain the lessons: one core, updated monthly, many wrappers.</a:t>
             </a:r>
             <a:endParaRPr lang="en-US" dirty="0"/>
           </a:p>
@@ -1215,7 +1215,7 @@
           <a:p>
             <a:r>
               <a:rPr lang="en-US" dirty="0"/>
-              <a:t>Ben: 'I thought about what Steve said and will lean into being the foundation for other AI courses, mainly as it would be great marketing.' This slide is that. The hand-off at the end of each path can point at CIPD's own courses or partner courses, and the baseline report is the thing Steve does not have today.</a:t>
+              <a:t>Ben: 'I thought about what Steve said and will lean into being the foundation for other AI courses, mainly as it would be great marketing.' This slide is that. The hand-off at the end of each path can point at CIPD's own courses or partner courses, and a visible per-student baseline is the thing Steve does not have today.</a:t>
             </a:r>
             <a:endParaRPr lang="en-US" dirty="0"/>
           </a:p>
@@ -2037,7 +2037,7 @@
                 <a:ea typeface="Cambria" pitchFamily="34" charset="-122"/>
                 <a:cs typeface="Cambria" pitchFamily="34" charset="-120"/>
               </a:rPr>
-              <a:t>Next steps</a:t>
+              <a:t>Possible next steps</a:t>
             </a:r>
             <a:endParaRPr lang="en-US" sz="3000" dirty="0"/>
           </a:p>
@@ -2142,7 +2142,7 @@
                 <a:ea typeface="Calibri" pitchFamily="34" charset="-122"/>
                 <a:cs typeface="Calibri" pitchFamily="34" charset="-120"/>
               </a:rPr>
-              <a:t>This week</a:t>
+              <a:t>Step 1</a:t>
             </a:r>
             <a:endParaRPr lang="en-US" sz="1400" dirty="0"/>
           </a:p>
@@ -2181,7 +2181,7 @@
                 <a:ea typeface="Calibri" pitchFamily="34" charset="-122"/>
                 <a:cs typeface="Calibri" pitchFamily="34" charset="-120"/>
               </a:rPr>
-              <a:t>Build the CIPD-curated edition prototype: branding, an HR path, a senior-leader path, cohort dashboard mock, baseline report.</a:t>
+              <a:t>Build the CIPD-curated edition prototype: co-branding, an HR path, a senior-leader path, the CIPD pathway on the certificate.</a:t>
             </a:r>
             <a:endParaRPr lang="en-US" sz="1400" dirty="0"/>
           </a:p>
@@ -2247,7 +2247,7 @@
                 <a:ea typeface="Calibri" pitchFamily="34" charset="-122"/>
                 <a:cs typeface="Calibri" pitchFamily="34" charset="-120"/>
               </a:rPr>
-              <a:t>Week after</a:t>
+              <a:t>Step 2</a:t>
             </a:r>
             <a:endParaRPr lang="en-US" sz="1400" dirty="0"/>
           </a:p>
@@ -2352,7 +2352,7 @@
                 <a:ea typeface="Calibri" pitchFamily="34" charset="-122"/>
                 <a:cs typeface="Calibri" pitchFamily="34" charset="-120"/>
               </a:rPr>
-              <a:t>September</a:t>
+              <a:t>Step 3</a:t>
             </a:r>
             <a:endParaRPr lang="en-US" sz="1400" dirty="0"/>
           </a:p>
@@ -2457,7 +2457,7 @@
                 <a:ea typeface="Calibri" pitchFamily="34" charset="-122"/>
                 <a:cs typeface="Calibri" pitchFamily="34" charset="-120"/>
               </a:rPr>
-              <a:t>Late Oct / early Nov</a:t>
+              <a:t>Step 4</a:t>
             </a:r>
             <a:endParaRPr lang="en-US" sz="1400" dirty="0"/>
           </a:p>
@@ -2496,7 +2496,7 @@
                 <a:ea typeface="Calibri" pitchFamily="34" charset="-122"/>
                 <a:cs typeface="Calibri" pitchFamily="34" charset="-120"/>
               </a:rPr>
-              <a:t>Reconvene with Steve once the new CEO has set direction; the baseline gap is in his October plan.</a:t>
+              <a:t>Late October / early November: reconvene with Steve once the new CEO has set direction; the baseline gap is in his October plan.</a:t>
             </a:r>
             <a:endParaRPr lang="en-US" sz="1400" dirty="0"/>
           </a:p>
@@ -8445,7 +8445,7 @@
                           <a:ea typeface="Calibri" pitchFamily="34" charset="-122"/>
                           <a:cs typeface="Calibri" pitchFamily="34" charset="-120"/>
                         </a:rPr>
-                        <a:t>Employer cohorts bought through CIPD, with a baseline report per cohort before they reach a classroom</a:t>
+                        <a:t>Members and their employers join through CIPD; each record shows the level reached before a classroom course</a:t>
                       </a:r>
                       <a:endParaRPr lang="en-US" sz="1150" dirty="0">
                         <a:latin typeface="Calibri" charset="0"/>
@@ -8668,7 +8668,7 @@
                 <a:ea typeface="Calibri" pitchFamily="34" charset="-122"/>
                 <a:cs typeface="Calibri" pitchFamily="34" charset="-120"/>
               </a:rPr>
-              <a:t>Teams already gives an employer its own dashboard and a choice of optional lessons. A curated edition turns that into a wrapper a partner controls.</a:t>
+              <a:t>Teams already gives an employer its own dashboard and a choice of optional lessons. A curated edition turns that into a co-branded path a partner shapes.</a:t>
             </a:r>
             <a:endParaRPr lang="en-US" sz="1500" dirty="0"/>
           </a:p>
@@ -8773,7 +8773,7 @@
                 <a:ea typeface="Calibri" pitchFamily="34" charset="-122"/>
                 <a:cs typeface="Calibri" pitchFamily="34" charset="-120"/>
               </a:rPr>
-              <a:t>cipd.gwth.ai or an address CIPD chooses. CIPD branding, CIPD framing pages, CIPD research woven in, member pricing.</a:t>
+              <a:t>Co-branded GWTH and CIPD. CIPD framing pages, CIPD research woven in, member pricing.</a:t>
             </a:r>
             <a:endParaRPr lang="en-US" sz="1100" dirty="0"/>
           </a:p>
@@ -8878,7 +8878,7 @@
                 <a:ea typeface="Calibri" pitchFamily="34" charset="-122"/>
                 <a:cs typeface="Calibri" pitchFamily="34" charset="-120"/>
               </a:rPr>
-              <a:t>Which lessons are core for an HR practitioner, an HRD, a recruiter; which optional lessons are switched on; cohort dashboard and baseline report.</a:t>
+              <a:t>Which lessons are core for an HR practitioner, an HRD, a recruiter; which optional lessons are switched on; the record shows the baseline reached.</a:t>
             </a:r>
             <a:endParaRPr lang="en-US" sz="1100" dirty="0"/>
           </a:p>
@@ -9125,7 +9125,7 @@
                 <a:ea typeface="Calibri" pitchFamily="34" charset="-122"/>
                 <a:cs typeface="Calibri" pitchFamily="34" charset="-120"/>
               </a:rPr>
-              <a:t>Co-branded or fully white-labelled, so it reads as CIPD-curated</a:t>
+              <a:t>Co-branded so it reads as CIPD-curated</a:t>
             </a:r>
             <a:endParaRPr lang="en-US" sz="1150" dirty="0"/>
           </a:p>
@@ -9434,7 +9434,7 @@
                 <a:ea typeface="Calibri" pitchFamily="34" charset="-122"/>
                 <a:cs typeface="Calibri" pitchFamily="34" charset="-120"/>
               </a:rPr>
-              <a:t>Member access and pricing; employer cohorts; a dashboard per cohort</a:t>
+              <a:t>Member access and pricing</a:t>
             </a:r>
             <a:endParaRPr lang="en-US" sz="1150" dirty="0"/>
           </a:p>
@@ -9537,7 +9537,7 @@
                 <a:ea typeface="Calibri" pitchFamily="34" charset="-122"/>
                 <a:cs typeface="Calibri" pitchFamily="34" charset="-120"/>
               </a:rPr>
-              <a:t>The record carries the CIPD pathway, and feeds a baseline report to the course tutor</a:t>
+              <a:t>The certificate says the student took the CIPD pathway</a:t>
             </a:r>
             <a:endParaRPr lang="en-US" sz="1150" dirty="0"/>
           </a:p>
@@ -10359,7 +10359,7 @@
                 <a:ea typeface="Calibri" pitchFamily="34" charset="-122"/>
                 <a:cs typeface="Calibri" pitchFamily="34" charset="-120"/>
               </a:rPr>
-              <a:t>Baseline report to the tutor</a:t>
+              <a:t>Baseline visible to the tutor</a:t>
             </a:r>
             <a:endParaRPr lang="en-US" sz="1350" dirty="0"/>
           </a:p>
@@ -10398,7 +10398,7 @@
                 <a:ea typeface="Calibri" pitchFamily="34" charset="-122"/>
                 <a:cs typeface="Calibri" pitchFamily="34" charset="-120"/>
               </a:rPr>
-              <a:t>Before a CIPD virtual-classroom or specialist course, the cohort's level is known. No more mixed rooms.</a:t>
+              <a:t>Before a CIPD virtual-classroom or specialist course, each student's record shows the level reached. No more mixed rooms.</a:t>
             </a:r>
             <a:endParaRPr lang="en-US" sz="1150" dirty="0"/>
           </a:p>

</xml_diff>